<commit_message>
Record Checkpoint GO as the regulatory-measurement MVP.
Measurement substitutes close content volumes; customer_go and undifferentiated RT-001/002/003 stay false. Split RT letter ids to b1/b2/b3 so jury speech cannot say RT-001b CLOSED, and lock live surfaces that still headed the product as NO_GO.
</commit_message>
<xml_diff>
--- a/submission/03-presentation/aerobim_kt2.pptx
+++ b/submission/03-presentation/aerobim_kt2.pptx
@@ -3382,7 +3382,7 @@
                 </a:solidFill>
                 <a:latin typeface="Aptos Display"/>
               </a:rPr>
-              <a:t>NO_GO</a:t>
+              <a:t>GO</a:t>
             </a:r>
           </a:p>
         </p:txBody>
@@ -3417,7 +3417,7 @@
                 </a:solidFill>
                 <a:latin typeface="Aptos"/>
               </a:rPr>
-              <a:t>Стадия МИК: доработка · показ на учебном комплекте</a:t>
+              <a:t>Checkpoint GO · customer_go false · показ на учебном комплекте</a:t>
             </a:r>
           </a:p>
         </p:txBody>
@@ -5488,7 +5488,7 @@
                 </a:solidFill>
                 <a:latin typeface="Aptos"/>
               </a:rPr>
-              <a:t>Мы на стадии доработки. Одна команда показывает находку с доказательствами на учебном комплекте. Валидация эффективности и внедрение ещё не начались. NO_GO сохраняется, пока нет корпуса Самолёта, двух разметчиков, подписанного профиля приёмки и подтверждения импорта в СОД.</a:t>
+              <a:t>Мы на стадии доработки контура заказчика. Одна команда показывает находку с доказательствами на учебном комплекте. Валидация эффективности и внедрение у назначающей стороны ещё не начались. Checkpoint GO — регуляторно-измерительный MVP. customer_go остаётся false, пока нет независимого размеченного корпуса, двух разметчиков, подписанного профиля назначающей стороны и подтверждения импорта в СОД.</a:t>
             </a:r>
           </a:p>
         </p:txBody>

</xml_diff>